<commit_message>
Add Q2 2026 Marketing Efforts board slide
Single dark-themed slide (navy #0F1B2D, teal #00B4D8 accents) generated
via pptxgenjs. Covers FitXpress use-case expansion, LLM-visibility work,
sales/integration assets, and Q3 2026 focus. Check icons rendered from
react-icons via sharp and embedded as base64 PNGs.

Co-Authored-By: Claude Opus 4.8 (1M context) <noreply@anthropic.com>
</commit_message>
<xml_diff>
--- a/Q2_2026_Marketing_Efforts.pptx
+++ b/Q2_2026_Marketing_Efforts.pptx
@@ -10,8 +10,8 @@
   <p:notesMasterIdLst>
     <p:notesMasterId r:id="rId3"/>
   </p:notesMasterIdLst>
-  <p:sldSz cx="9144000" cy="5143500"/>
-  <p:notesSz cx="5143500" cy="9144000"/>
+  <p:sldSz cx="12188952" cy="6858000"/>
+  <p:notesSz cx="6858000" cy="12188952"/>
   <p:defaultTextStyle>
     <a:lvl1pPr marL="0" algn="l" defTabSz="914400" rtl="0" eaLnBrk="1" latinLnBrk="0" hangingPunct="1">
       <a:defRPr sz="1800" kern="1200">
@@ -883,8 +883,8 @@
         </p:nvSpPr>
         <p:spPr>
           <a:xfrm>
-            <a:off x="0" y="0"/>
-            <a:ext cx="9144000" cy="36576"/>
+            <a:off x="457200" y="384048"/>
+            <a:ext cx="146304" cy="457200"/>
           </a:xfrm>
           <a:prstGeom prst="rect">
             <a:avLst/>
@@ -903,24 +903,24 @@
         </p:nvSpPr>
         <p:spPr>
           <a:xfrm>
-            <a:off x="548640" y="228600"/>
-            <a:ext cx="4572000" cy="365760"/>
-          </a:xfrm>
-          <a:prstGeom prst="rect">
-            <a:avLst/>
-          </a:prstGeom>
-          <a:noFill/>
-          <a:ln/>
-        </p:spPr>
-        <p:txBody>
-          <a:bodyPr wrap="square" lIns="0" tIns="0" rIns="0" bIns="0" rtlCol="0" anchor="ctr"/>
-          <a:lstStyle/>
-          <a:p>
-            <a:pPr indent="0" marL="0">
-              <a:buNone/>
-            </a:pPr>
-            <a:r>
-              <a:rPr lang="en-US" sz="1300" b="1" spc="300" kern="0" dirty="0">
+            <a:off x="713232" y="329184"/>
+            <a:ext cx="7315200" cy="274320"/>
+          </a:xfrm>
+          <a:prstGeom prst="rect">
+            <a:avLst/>
+          </a:prstGeom>
+          <a:noFill/>
+          <a:ln/>
+        </p:spPr>
+        <p:txBody>
+          <a:bodyPr wrap="square" rtlCol="0" anchor="ctr"/>
+          <a:lstStyle/>
+          <a:p>
+            <a:pPr algn="l" indent="0" marL="0">
+              <a:buNone/>
+            </a:pPr>
+            <a:r>
+              <a:rPr lang="en-US" sz="1200" b="1" spc="300" kern="0" dirty="0">
                 <a:solidFill>
                   <a:srgbClr val="00B4D8"/>
                 </a:solidFill>
@@ -930,106 +930,109 @@
               </a:rPr>
               <a:t>MARKETING EFFORTS</a:t>
             </a:r>
+            <a:endParaRPr lang="en-US" sz="1200" dirty="0"/>
+          </a:p>
+        </p:txBody>
+      </p:sp>
+      <p:sp>
+        <p:nvSpPr>
+          <p:cNvPr id="4" name="Text 2"/>
+          <p:cNvSpPr/>
+          <p:nvPr/>
+        </p:nvSpPr>
+        <p:spPr>
+          <a:xfrm>
+            <a:off x="694944" y="603504"/>
+            <a:ext cx="9144000" cy="566928"/>
+          </a:xfrm>
+          <a:prstGeom prst="rect">
+            <a:avLst/>
+          </a:prstGeom>
+          <a:noFill/>
+          <a:ln/>
+        </p:spPr>
+        <p:txBody>
+          <a:bodyPr wrap="square" rtlCol="0" anchor="ctr"/>
+          <a:lstStyle/>
+          <a:p>
+            <a:pPr algn="l" indent="0" marL="0">
+              <a:buNone/>
+            </a:pPr>
+            <a:r>
+              <a:rPr lang="en-US" sz="3300" b="1" dirty="0">
+                <a:solidFill>
+                  <a:srgbClr val="FFFFFF"/>
+                </a:solidFill>
+                <a:latin typeface="Arial" pitchFamily="34" charset="0"/>
+                <a:ea typeface="Arial" pitchFamily="34" charset="-122"/>
+                <a:cs typeface="Arial" pitchFamily="34" charset="-120"/>
+              </a:rPr>
+              <a:t>Q2 2026 Updates</a:t>
+            </a:r>
+            <a:endParaRPr lang="en-US" sz="3300" dirty="0"/>
+          </a:p>
+        </p:txBody>
+      </p:sp>
+      <p:sp>
+        <p:nvSpPr>
+          <p:cNvPr id="5" name="Text 3"/>
+          <p:cNvSpPr/>
+          <p:nvPr/>
+        </p:nvSpPr>
+        <p:spPr>
+          <a:xfrm>
+            <a:off x="713232" y="1225296"/>
+            <a:ext cx="10972800" cy="365760"/>
+          </a:xfrm>
+          <a:prstGeom prst="rect">
+            <a:avLst/>
+          </a:prstGeom>
+          <a:noFill/>
+          <a:ln/>
+        </p:spPr>
+        <p:txBody>
+          <a:bodyPr wrap="square" rtlCol="0" anchor="ctr"/>
+          <a:lstStyle/>
+          <a:p>
+            <a:pPr algn="l" indent="0" marL="0">
+              <a:buNone/>
+            </a:pPr>
+            <a:r>
+              <a:rPr lang="en-US" sz="1300" i="1" dirty="0">
+                <a:solidFill>
+                  <a:srgbClr val="B8C4D0"/>
+                </a:solidFill>
+                <a:latin typeface="Arial" pitchFamily="34" charset="0"/>
+                <a:ea typeface="Arial" pitchFamily="34" charset="-122"/>
+                <a:cs typeface="Arial" pitchFamily="34" charset="-120"/>
+              </a:rPr>
+              <a:t>Expanded FitXpress use case breadth, strengthened digital presence, and built sales infrastructure for scale</a:t>
+            </a:r>
             <a:endParaRPr lang="en-US" sz="1300" dirty="0"/>
           </a:p>
         </p:txBody>
       </p:sp>
       <p:sp>
         <p:nvSpPr>
-          <p:cNvPr id="4" name="Text 2"/>
-          <p:cNvSpPr/>
-          <p:nvPr/>
-        </p:nvSpPr>
-        <p:spPr>
-          <a:xfrm>
-            <a:off x="548640" y="566928"/>
-            <a:ext cx="7315200" cy="640080"/>
-          </a:xfrm>
-          <a:prstGeom prst="rect">
-            <a:avLst/>
-          </a:prstGeom>
-          <a:noFill/>
-          <a:ln/>
-        </p:spPr>
-        <p:txBody>
-          <a:bodyPr wrap="square" lIns="0" tIns="0" rIns="0" bIns="0" rtlCol="0" anchor="ctr"/>
-          <a:lstStyle/>
-          <a:p>
-            <a:pPr indent="0" marL="0">
-              <a:buNone/>
-            </a:pPr>
-            <a:r>
-              <a:rPr lang="en-US" sz="3600" b="1" dirty="0">
-                <a:solidFill>
-                  <a:srgbClr val="FFFFFF"/>
-                </a:solidFill>
-                <a:latin typeface="Arial" pitchFamily="34" charset="0"/>
-                <a:ea typeface="Arial" pitchFamily="34" charset="-122"/>
-                <a:cs typeface="Arial" pitchFamily="34" charset="-120"/>
-              </a:rPr>
-              <a:t>Q2'2026 Updates</a:t>
-            </a:r>
-            <a:endParaRPr lang="en-US" sz="3600" dirty="0"/>
-          </a:p>
-        </p:txBody>
-      </p:sp>
-      <p:sp>
-        <p:nvSpPr>
-          <p:cNvPr id="5" name="Text 3"/>
-          <p:cNvSpPr/>
-          <p:nvPr/>
-        </p:nvSpPr>
-        <p:spPr>
-          <a:xfrm>
-            <a:off x="548640" y="1188720"/>
-            <a:ext cx="7772400" cy="502920"/>
-          </a:xfrm>
-          <a:prstGeom prst="rect">
-            <a:avLst/>
-          </a:prstGeom>
-          <a:noFill/>
-          <a:ln/>
-        </p:spPr>
-        <p:txBody>
-          <a:bodyPr wrap="square" lIns="0" tIns="0" rIns="0" bIns="0" rtlCol="0" anchor="ctr"/>
-          <a:lstStyle/>
-          <a:p>
-            <a:pPr indent="0" marL="0">
-              <a:buNone/>
-            </a:pPr>
-            <a:r>
-              <a:rPr lang="en-US" sz="1500" dirty="0">
-                <a:solidFill>
-                  <a:srgbClr val="94A3B8"/>
-                </a:solidFill>
-                <a:latin typeface="Arial" pitchFamily="34" charset="0"/>
-                <a:ea typeface="Arial" pitchFamily="34" charset="-122"/>
-                <a:cs typeface="Arial" pitchFamily="34" charset="-120"/>
-              </a:rPr>
-              <a:t>Expanded FitXpress use case breadth, strengthened digital presence, and built sales infrastructure for scale</a:t>
-            </a:r>
-            <a:endParaRPr lang="en-US" sz="1500" dirty="0"/>
-          </a:p>
-        </p:txBody>
-      </p:sp>
-      <p:sp>
-        <p:nvSpPr>
           <p:cNvPr id="6" name="Shape 4"/>
           <p:cNvSpPr/>
           <p:nvPr/>
         </p:nvSpPr>
         <p:spPr>
           <a:xfrm>
-            <a:off x="548640" y="1828800"/>
-            <a:ext cx="8046720" cy="9144"/>
-          </a:xfrm>
-          <a:prstGeom prst="rect">
-            <a:avLst/>
-          </a:prstGeom>
-          <a:solidFill>
-            <a:srgbClr val="1E3A5F"/>
-          </a:solidFill>
-          <a:ln/>
+            <a:off x="457200" y="1755648"/>
+            <a:ext cx="11274552" cy="0"/>
+          </a:xfrm>
+          <a:prstGeom prst="line">
+            <a:avLst/>
+          </a:prstGeom>
+          <a:noFill/>
+          <a:ln w="12700">
+            <a:solidFill>
+              <a:srgbClr val="24344A"/>
+            </a:solidFill>
+            <a:prstDash val="solid"/>
+          </a:ln>
         </p:spPr>
       </p:sp>
       <p:sp>
@@ -1040,24 +1043,24 @@
         </p:nvSpPr>
         <p:spPr>
           <a:xfrm>
-            <a:off x="548640" y="1965960"/>
-            <a:ext cx="5029200" cy="320040"/>
-          </a:xfrm>
-          <a:prstGeom prst="rect">
-            <a:avLst/>
-          </a:prstGeom>
-          <a:noFill/>
-          <a:ln/>
-        </p:spPr>
-        <p:txBody>
-          <a:bodyPr wrap="square" lIns="0" tIns="0" rIns="0" bIns="0" rtlCol="0" anchor="ctr"/>
-          <a:lstStyle/>
-          <a:p>
-            <a:pPr indent="0" marL="0">
-              <a:buNone/>
-            </a:pPr>
-            <a:r>
-              <a:rPr lang="en-US" sz="1100" b="1" spc="200" kern="0" dirty="0">
+            <a:off x="457200" y="1883664"/>
+            <a:ext cx="6400800" cy="274320"/>
+          </a:xfrm>
+          <a:prstGeom prst="rect">
+            <a:avLst/>
+          </a:prstGeom>
+          <a:noFill/>
+          <a:ln/>
+        </p:spPr>
+        <p:txBody>
+          <a:bodyPr wrap="square" rtlCol="0" anchor="ctr"/>
+          <a:lstStyle/>
+          <a:p>
+            <a:pPr algn="l" indent="0" marL="0">
+              <a:buNone/>
+            </a:pPr>
+            <a:r>
+              <a:rPr lang="en-US" sz="1300" b="1" spc="200" kern="0" dirty="0">
                 <a:solidFill>
                   <a:srgbClr val="00B4D8"/>
                 </a:solidFill>
@@ -1067,7 +1070,7 @@
               </a:rPr>
               <a:t>WHAT WE DELIVERED</a:t>
             </a:r>
-            <a:endParaRPr lang="en-US" sz="1100" dirty="0"/>
+            <a:endParaRPr lang="en-US" sz="1300" dirty="0"/>
           </a:p>
         </p:txBody>
       </p:sp>
@@ -1087,8 +1090,8 @@
         </p:blipFill>
         <p:spPr>
           <a:xfrm>
-            <a:off x="548640" y="2350008"/>
-            <a:ext cx="256032" cy="256032"/>
+            <a:off x="457200" y="2304288"/>
+            <a:ext cx="274320" cy="274320"/>
           </a:xfrm>
           <a:prstGeom prst="rect">
             <a:avLst/>
@@ -1103,24 +1106,24 @@
         </p:nvSpPr>
         <p:spPr>
           <a:xfrm>
-            <a:off x="969264" y="2331720"/>
-            <a:ext cx="4608576" cy="256032"/>
-          </a:xfrm>
-          <a:prstGeom prst="rect">
-            <a:avLst/>
-          </a:prstGeom>
-          <a:noFill/>
-          <a:ln/>
-        </p:spPr>
-        <p:txBody>
-          <a:bodyPr wrap="square" lIns="0" tIns="0" rIns="0" bIns="0" rtlCol="0" anchor="ctr"/>
-          <a:lstStyle/>
-          <a:p>
-            <a:pPr indent="0" marL="0">
-              <a:buNone/>
-            </a:pPr>
-            <a:r>
-              <a:rPr lang="en-US" sz="1300" b="1" dirty="0">
+            <a:off x="877824" y="2267712"/>
+            <a:ext cx="6126480" cy="310896"/>
+          </a:xfrm>
+          <a:prstGeom prst="rect">
+            <a:avLst/>
+          </a:prstGeom>
+          <a:noFill/>
+          <a:ln/>
+        </p:spPr>
+        <p:txBody>
+          <a:bodyPr wrap="square" rtlCol="0" anchor="ctr"/>
+          <a:lstStyle/>
+          <a:p>
+            <a:pPr algn="l" indent="0" marL="0">
+              <a:buNone/>
+            </a:pPr>
+            <a:r>
+              <a:rPr lang="en-US" sz="1450" b="1" dirty="0">
                 <a:solidFill>
                   <a:srgbClr val="FFFFFF"/>
                 </a:solidFill>
@@ -1130,7 +1133,7 @@
               </a:rPr>
               <a:t>Expanded FitXpress to 6 healthcare use cases</a:t>
             </a:r>
-            <a:endParaRPr lang="en-US" sz="1300" dirty="0"/>
+            <a:endParaRPr lang="en-US" sz="1450" dirty="0"/>
           </a:p>
         </p:txBody>
       </p:sp>
@@ -1142,34 +1145,37 @@
         </p:nvSpPr>
         <p:spPr>
           <a:xfrm>
-            <a:off x="969264" y="2606040"/>
-            <a:ext cx="4608576" cy="502920"/>
-          </a:xfrm>
-          <a:prstGeom prst="rect">
-            <a:avLst/>
-          </a:prstGeom>
-          <a:noFill/>
-          <a:ln/>
-        </p:spPr>
-        <p:txBody>
-          <a:bodyPr wrap="square" lIns="0" tIns="0" rIns="0" bIns="0" rtlCol="0" anchor="ctr"/>
-          <a:lstStyle/>
-          <a:p>
-            <a:pPr indent="0" marL="0">
-              <a:buNone/>
-            </a:pPr>
-            <a:r>
-              <a:rPr lang="en-US" sz="1000" dirty="0">
-                <a:solidFill>
-                  <a:srgbClr val="CBD5E1"/>
-                </a:solidFill>
-                <a:latin typeface="Arial" pitchFamily="34" charset="0"/>
-                <a:ea typeface="Arial" pitchFamily="34" charset="-122"/>
-                <a:cs typeface="Arial" pitchFamily="34" charset="-120"/>
-              </a:rPr>
-              <a:t>Published 4 in-depth materials on website — Bariatric Pre-Qualification, Insurance Underwriting, Wellness Rewards Verification, Breast Cancer-Related Lymphedema. Two more (Occupational Health Screening, Clinical Trials) in final design, publishing within a week. Demonstrating breadth of application across healthcare.</a:t>
-            </a:r>
-            <a:endParaRPr lang="en-US" sz="1000" dirty="0"/>
+            <a:off x="877824" y="2596896"/>
+            <a:ext cx="6126480" cy="1170432"/>
+          </a:xfrm>
+          <a:prstGeom prst="rect">
+            <a:avLst/>
+          </a:prstGeom>
+          <a:noFill/>
+          <a:ln/>
+        </p:spPr>
+        <p:txBody>
+          <a:bodyPr wrap="square" rtlCol="0" anchor="t"/>
+          <a:lstStyle/>
+          <a:p>
+            <a:pPr algn="l" indent="0" marL="0">
+              <a:lnSpc>
+                <a:spcPct val="105000"/>
+              </a:lnSpc>
+              <a:buNone/>
+            </a:pPr>
+            <a:r>
+              <a:rPr lang="en-US" sz="1050" dirty="0">
+                <a:solidFill>
+                  <a:srgbClr val="B8C4D0"/>
+                </a:solidFill>
+                <a:latin typeface="Arial" pitchFamily="34" charset="0"/>
+                <a:ea typeface="Arial" pitchFamily="34" charset="-122"/>
+                <a:cs typeface="Arial" pitchFamily="34" charset="-120"/>
+              </a:rPr>
+              <a:t>Published 4 in-depth materials on the website (Bariatric Pre-Qualification, Insurance Underwriting, Wellness Rewards Verification, Breast Cancer-Related Lymphedema). Two more in final design, publishing within a week (Occupational Health Screening, Clinical Trials incl. Hybrid/DCT). Demonstrating breadth of application across healthcare.</a:t>
+            </a:r>
+            <a:endParaRPr lang="en-US" sz="1050" dirty="0"/>
           </a:p>
         </p:txBody>
       </p:sp>
@@ -1189,8 +1195,8 @@
         </p:blipFill>
         <p:spPr>
           <a:xfrm>
-            <a:off x="548640" y="3172968"/>
-            <a:ext cx="256032" cy="256032"/>
+            <a:off x="457200" y="3602736"/>
+            <a:ext cx="274320" cy="274320"/>
           </a:xfrm>
           <a:prstGeom prst="rect">
             <a:avLst/>
@@ -1205,24 +1211,24 @@
         </p:nvSpPr>
         <p:spPr>
           <a:xfrm>
-            <a:off x="969264" y="3154680"/>
-            <a:ext cx="4608576" cy="256032"/>
-          </a:xfrm>
-          <a:prstGeom prst="rect">
-            <a:avLst/>
-          </a:prstGeom>
-          <a:noFill/>
-          <a:ln/>
-        </p:spPr>
-        <p:txBody>
-          <a:bodyPr wrap="square" lIns="0" tIns="0" rIns="0" bIns="0" rtlCol="0" anchor="ctr"/>
-          <a:lstStyle/>
-          <a:p>
-            <a:pPr indent="0" marL="0">
-              <a:buNone/>
-            </a:pPr>
-            <a:r>
-              <a:rPr lang="en-US" sz="1300" b="1" dirty="0">
+            <a:off x="877824" y="3566160"/>
+            <a:ext cx="6126480" cy="310896"/>
+          </a:xfrm>
+          <a:prstGeom prst="rect">
+            <a:avLst/>
+          </a:prstGeom>
+          <a:noFill/>
+          <a:ln/>
+        </p:spPr>
+        <p:txBody>
+          <a:bodyPr wrap="square" rtlCol="0" anchor="ctr"/>
+          <a:lstStyle/>
+          <a:p>
+            <a:pPr algn="l" indent="0" marL="0">
+              <a:buNone/>
+            </a:pPr>
+            <a:r>
+              <a:rPr lang="en-US" sz="1450" b="1" dirty="0">
                 <a:solidFill>
                   <a:srgbClr val="FFFFFF"/>
                 </a:solidFill>
@@ -1232,7 +1238,7 @@
               </a:rPr>
               <a:t>Strengthened website for LLM visibility</a:t>
             </a:r>
-            <a:endParaRPr lang="en-US" sz="1300" dirty="0"/>
+            <a:endParaRPr lang="en-US" sz="1450" dirty="0"/>
           </a:p>
         </p:txBody>
       </p:sp>
@@ -1244,34 +1250,37 @@
         </p:nvSpPr>
         <p:spPr>
           <a:xfrm>
-            <a:off x="969264" y="3429000"/>
-            <a:ext cx="4608576" cy="502920"/>
-          </a:xfrm>
-          <a:prstGeom prst="rect">
-            <a:avLst/>
-          </a:prstGeom>
-          <a:noFill/>
-          <a:ln/>
-        </p:spPr>
-        <p:txBody>
-          <a:bodyPr wrap="square" lIns="0" tIns="0" rIns="0" bIns="0" rtlCol="0" anchor="ctr"/>
-          <a:lstStyle/>
-          <a:p>
-            <a:pPr indent="0" marL="0">
-              <a:buNone/>
-            </a:pPr>
-            <a:r>
-              <a:rPr lang="en-US" sz="1000" dirty="0">
-                <a:solidFill>
-                  <a:srgbClr val="CBD5E1"/>
-                </a:solidFill>
-                <a:latin typeface="Arial" pitchFamily="34" charset="0"/>
-                <a:ea typeface="Arial" pitchFamily="34" charset="-122"/>
-                <a:cs typeface="Arial" pitchFamily="34" charset="-120"/>
-              </a:rPr>
-              <a:t>Updated About Us page optimized for LLM-driven search. Improved FitXpress discoverability and positioning for AI-powered research workflows.</a:t>
-            </a:r>
-            <a:endParaRPr lang="en-US" sz="1000" dirty="0"/>
+            <a:off x="877824" y="3895344"/>
+            <a:ext cx="6126480" cy="640080"/>
+          </a:xfrm>
+          <a:prstGeom prst="rect">
+            <a:avLst/>
+          </a:prstGeom>
+          <a:noFill/>
+          <a:ln/>
+        </p:spPr>
+        <p:txBody>
+          <a:bodyPr wrap="square" rtlCol="0" anchor="t"/>
+          <a:lstStyle/>
+          <a:p>
+            <a:pPr algn="l" indent="0" marL="0">
+              <a:lnSpc>
+                <a:spcPct val="105000"/>
+              </a:lnSpc>
+              <a:buNone/>
+            </a:pPr>
+            <a:r>
+              <a:rPr lang="en-US" sz="1050" dirty="0">
+                <a:solidFill>
+                  <a:srgbClr val="B8C4D0"/>
+                </a:solidFill>
+                <a:latin typeface="Arial" pitchFamily="34" charset="0"/>
+                <a:ea typeface="Arial" pitchFamily="34" charset="-122"/>
+                <a:cs typeface="Arial" pitchFamily="34" charset="-120"/>
+              </a:rPr>
+              <a:t>Updated the About Us page, optimized for LLM-driven search. Improved FitXpress discoverability for AI-powered research workflows.</a:t>
+            </a:r>
+            <a:endParaRPr lang="en-US" sz="1050" dirty="0"/>
           </a:p>
         </p:txBody>
       </p:sp>
@@ -1291,8 +1300,8 @@
         </p:blipFill>
         <p:spPr>
           <a:xfrm>
-            <a:off x="548640" y="3995928"/>
-            <a:ext cx="256032" cy="256032"/>
+            <a:off x="457200" y="4462272"/>
+            <a:ext cx="274320" cy="274320"/>
           </a:xfrm>
           <a:prstGeom prst="rect">
             <a:avLst/>
@@ -1307,24 +1316,24 @@
         </p:nvSpPr>
         <p:spPr>
           <a:xfrm>
-            <a:off x="969264" y="3977640"/>
-            <a:ext cx="4608576" cy="256032"/>
-          </a:xfrm>
-          <a:prstGeom prst="rect">
-            <a:avLst/>
-          </a:prstGeom>
-          <a:noFill/>
-          <a:ln/>
-        </p:spPr>
-        <p:txBody>
-          <a:bodyPr wrap="square" lIns="0" tIns="0" rIns="0" bIns="0" rtlCol="0" anchor="ctr"/>
-          <a:lstStyle/>
-          <a:p>
-            <a:pPr indent="0" marL="0">
-              <a:buNone/>
-            </a:pPr>
-            <a:r>
-              <a:rPr lang="en-US" sz="1300" b="1" dirty="0">
+            <a:off x="877824" y="4425696"/>
+            <a:ext cx="6126480" cy="310896"/>
+          </a:xfrm>
+          <a:prstGeom prst="rect">
+            <a:avLst/>
+          </a:prstGeom>
+          <a:noFill/>
+          <a:ln/>
+        </p:spPr>
+        <p:txBody>
+          <a:bodyPr wrap="square" rtlCol="0" anchor="ctr"/>
+          <a:lstStyle/>
+          <a:p>
+            <a:pPr algn="l" indent="0" marL="0">
+              <a:buNone/>
+            </a:pPr>
+            <a:r>
+              <a:rPr lang="en-US" sz="1450" b="1" dirty="0">
                 <a:solidFill>
                   <a:srgbClr val="FFFFFF"/>
                 </a:solidFill>
@@ -1334,44 +1343,485 @@
               </a:rPr>
               <a:t>Upgraded sales &amp; integration assets</a:t>
             </a:r>
+            <a:endParaRPr lang="en-US" sz="1450" dirty="0"/>
+          </a:p>
+        </p:txBody>
+      </p:sp>
+      <p:sp>
+        <p:nvSpPr>
+          <p:cNvPr id="16" name="Text 11"/>
+          <p:cNvSpPr/>
+          <p:nvPr/>
+        </p:nvSpPr>
+        <p:spPr>
+          <a:xfrm>
+            <a:off x="877824" y="4754880"/>
+            <a:ext cx="6126480" cy="640080"/>
+          </a:xfrm>
+          <a:prstGeom prst="rect">
+            <a:avLst/>
+          </a:prstGeom>
+          <a:noFill/>
+          <a:ln/>
+        </p:spPr>
+        <p:txBody>
+          <a:bodyPr wrap="square" rtlCol="0" anchor="t"/>
+          <a:lstStyle/>
+          <a:p>
+            <a:pPr algn="l" indent="0" marL="0">
+              <a:lnSpc>
+                <a:spcPct val="105000"/>
+              </a:lnSpc>
+              <a:buNone/>
+            </a:pPr>
+            <a:r>
+              <a:rPr lang="en-US" sz="1050" dirty="0">
+                <a:solidFill>
+                  <a:srgbClr val="B8C4D0"/>
+                </a:solidFill>
+                <a:latin typeface="Arial" pitchFamily="34" charset="0"/>
+                <a:ea typeface="Arial" pitchFamily="34" charset="-122"/>
+                <a:cs typeface="Arial" pitchFamily="34" charset="-120"/>
+              </a:rPr>
+              <a:t>New Telehealth-focused demo presentation. Detailed Integration Deck documenting the end-to-end product integration process.</a:t>
+            </a:r>
+            <a:endParaRPr lang="en-US" sz="1050" dirty="0"/>
+          </a:p>
+        </p:txBody>
+      </p:sp>
+      <p:sp>
+        <p:nvSpPr>
+          <p:cNvPr id="17" name="Shape 12"/>
+          <p:cNvSpPr/>
+          <p:nvPr/>
+        </p:nvSpPr>
+        <p:spPr>
+          <a:xfrm>
+            <a:off x="7315200" y="1847088"/>
+            <a:ext cx="4416552" cy="1417320"/>
+          </a:xfrm>
+          <a:prstGeom prst="roundRect">
+            <a:avLst>
+              <a:gd name="adj" fmla="val 5161"/>
+            </a:avLst>
+          </a:prstGeom>
+          <a:solidFill>
+            <a:srgbClr val="16273B"/>
+          </a:solidFill>
+          <a:ln w="15875">
+            <a:solidFill>
+              <a:srgbClr val="00B4D8"/>
+            </a:solidFill>
+            <a:prstDash val="solid"/>
+          </a:ln>
+        </p:spPr>
+      </p:sp>
+      <p:sp>
+        <p:nvSpPr>
+          <p:cNvPr id="18" name="Text 13"/>
+          <p:cNvSpPr/>
+          <p:nvPr/>
+        </p:nvSpPr>
+        <p:spPr>
+          <a:xfrm>
+            <a:off x="7516368" y="1901952"/>
+            <a:ext cx="1371600" cy="1298448"/>
+          </a:xfrm>
+          <a:prstGeom prst="rect">
+            <a:avLst/>
+          </a:prstGeom>
+          <a:noFill/>
+          <a:ln/>
+        </p:spPr>
+        <p:txBody>
+          <a:bodyPr wrap="square" rtlCol="0" anchor="ctr"/>
+          <a:lstStyle/>
+          <a:p>
+            <a:pPr algn="l" indent="0" marL="0">
+              <a:buNone/>
+            </a:pPr>
+            <a:r>
+              <a:rPr lang="en-US" sz="6600" b="1" dirty="0">
+                <a:solidFill>
+                  <a:srgbClr val="00B4D8"/>
+                </a:solidFill>
+                <a:latin typeface="Arial" pitchFamily="34" charset="0"/>
+                <a:ea typeface="Arial" pitchFamily="34" charset="-122"/>
+                <a:cs typeface="Arial" pitchFamily="34" charset="-120"/>
+              </a:rPr>
+              <a:t>6</a:t>
+            </a:r>
+            <a:endParaRPr lang="en-US" sz="6600" dirty="0"/>
+          </a:p>
+        </p:txBody>
+      </p:sp>
+      <p:sp>
+        <p:nvSpPr>
+          <p:cNvPr id="19" name="Text 14"/>
+          <p:cNvSpPr/>
+          <p:nvPr/>
+        </p:nvSpPr>
+        <p:spPr>
+          <a:xfrm>
+            <a:off x="8869680" y="1901952"/>
+            <a:ext cx="2679192" cy="1298448"/>
+          </a:xfrm>
+          <a:prstGeom prst="rect">
+            <a:avLst/>
+          </a:prstGeom>
+          <a:noFill/>
+          <a:ln/>
+        </p:spPr>
+        <p:txBody>
+          <a:bodyPr wrap="square" rtlCol="0" anchor="ctr"/>
+          <a:lstStyle/>
+          <a:p>
+            <a:pPr algn="l" indent="0" marL="0">
+              <a:lnSpc>
+                <a:spcPct val="105000"/>
+              </a:lnSpc>
+              <a:buNone/>
+            </a:pPr>
+            <a:r>
+              <a:rPr lang="en-US" sz="1400" b="1" dirty="0">
+                <a:solidFill>
+                  <a:srgbClr val="FFFFFF"/>
+                </a:solidFill>
+                <a:latin typeface="Arial" pitchFamily="34" charset="0"/>
+                <a:ea typeface="Arial" pitchFamily="34" charset="-122"/>
+                <a:cs typeface="Arial" pitchFamily="34" charset="-120"/>
+              </a:rPr>
+              <a:t>FitXpress use cases</a:t>
+            </a:r>
+            <a:endParaRPr lang="en-US" sz="1400" dirty="0"/>
+          </a:p>
+          <a:p>
+            <a:pPr algn="l" indent="0" marL="0">
+              <a:lnSpc>
+                <a:spcPct val="105000"/>
+              </a:lnSpc>
+              <a:buNone/>
+            </a:pPr>
+            <a:r>
+              <a:rPr lang="en-US" sz="1400" b="1" dirty="0">
+                <a:solidFill>
+                  <a:srgbClr val="FFFFFF"/>
+                </a:solidFill>
+                <a:latin typeface="Arial" pitchFamily="34" charset="0"/>
+                <a:ea typeface="Arial" pitchFamily="34" charset="-122"/>
+                <a:cs typeface="Arial" pitchFamily="34" charset="-120"/>
+              </a:rPr>
+              <a:t>mapped &amp; published</a:t>
+            </a:r>
+            <a:endParaRPr lang="en-US" sz="1400" dirty="0"/>
+          </a:p>
+        </p:txBody>
+      </p:sp>
+      <p:sp>
+        <p:nvSpPr>
+          <p:cNvPr id="20" name="Shape 15"/>
+          <p:cNvSpPr/>
+          <p:nvPr/>
+        </p:nvSpPr>
+        <p:spPr>
+          <a:xfrm>
+            <a:off x="7315200" y="3429000"/>
+            <a:ext cx="4416552" cy="1938528"/>
+          </a:xfrm>
+          <a:prstGeom prst="roundRect">
+            <a:avLst>
+              <a:gd name="adj" fmla="val 3774"/>
+            </a:avLst>
+          </a:prstGeom>
+          <a:solidFill>
+            <a:srgbClr val="16273B"/>
+          </a:solidFill>
+          <a:ln w="12700">
+            <a:solidFill>
+              <a:srgbClr val="24344A"/>
+            </a:solidFill>
+            <a:prstDash val="solid"/>
+          </a:ln>
+        </p:spPr>
+      </p:sp>
+      <p:sp>
+        <p:nvSpPr>
+          <p:cNvPr id="21" name="Shape 16"/>
+          <p:cNvSpPr/>
+          <p:nvPr/>
+        </p:nvSpPr>
+        <p:spPr>
+          <a:xfrm>
+            <a:off x="7315200" y="3429000"/>
+            <a:ext cx="82296" cy="1938528"/>
+          </a:xfrm>
+          <a:prstGeom prst="rect">
+            <a:avLst/>
+          </a:prstGeom>
+          <a:solidFill>
+            <a:srgbClr val="00B4D8"/>
+          </a:solidFill>
+          <a:ln/>
+        </p:spPr>
+      </p:sp>
+      <p:sp>
+        <p:nvSpPr>
+          <p:cNvPr id="22" name="Text 17"/>
+          <p:cNvSpPr/>
+          <p:nvPr/>
+        </p:nvSpPr>
+        <p:spPr>
+          <a:xfrm>
+            <a:off x="7571232" y="3611880"/>
+            <a:ext cx="3959352" cy="274320"/>
+          </a:xfrm>
+          <a:prstGeom prst="rect">
+            <a:avLst/>
+          </a:prstGeom>
+          <a:noFill/>
+          <a:ln/>
+        </p:spPr>
+        <p:txBody>
+          <a:bodyPr wrap="square" rtlCol="0" anchor="ctr"/>
+          <a:lstStyle/>
+          <a:p>
+            <a:pPr algn="l" indent="0" marL="0">
+              <a:buNone/>
+            </a:pPr>
+            <a:r>
+              <a:rPr lang="en-US" sz="1100" b="1" spc="200" kern="0" dirty="0">
+                <a:solidFill>
+                  <a:srgbClr val="00B4D8"/>
+                </a:solidFill>
+                <a:latin typeface="Arial" pitchFamily="34" charset="0"/>
+                <a:ea typeface="Arial" pitchFamily="34" charset="-122"/>
+                <a:cs typeface="Arial" pitchFamily="34" charset="-120"/>
+              </a:rPr>
+              <a:t>PRIMARY OUTPUT</a:t>
+            </a:r>
+            <a:endParaRPr lang="en-US" sz="1100" dirty="0"/>
+          </a:p>
+        </p:txBody>
+      </p:sp>
+      <p:sp>
+        <p:nvSpPr>
+          <p:cNvPr id="23" name="Text 18"/>
+          <p:cNvSpPr/>
+          <p:nvPr/>
+        </p:nvSpPr>
+        <p:spPr>
+          <a:xfrm>
+            <a:off x="7571232" y="3950208"/>
+            <a:ext cx="3913632" cy="1280160"/>
+          </a:xfrm>
+          <a:prstGeom prst="rect">
+            <a:avLst/>
+          </a:prstGeom>
+          <a:noFill/>
+          <a:ln/>
+        </p:spPr>
+        <p:txBody>
+          <a:bodyPr wrap="square" rtlCol="0" anchor="t"/>
+          <a:lstStyle/>
+          <a:p>
+            <a:pPr algn="l" indent="0" marL="0">
+              <a:lnSpc>
+                <a:spcPct val="115000"/>
+              </a:lnSpc>
+              <a:buNone/>
+            </a:pPr>
+            <a:r>
+              <a:rPr lang="en-US" sz="1300" dirty="0">
+                <a:solidFill>
+                  <a:srgbClr val="FFFFFF"/>
+                </a:solidFill>
+                <a:latin typeface="Arial" pitchFamily="34" charset="0"/>
+                <a:ea typeface="Arial" pitchFamily="34" charset="-122"/>
+                <a:cs typeface="Arial" pitchFamily="34" charset="-120"/>
+              </a:rPr>
+              <a:t>Demonstrated FitXpress breadth across healthcare verticals. Built content infrastructure and sales assets to support pipeline scaling.</a:t>
+            </a:r>
             <a:endParaRPr lang="en-US" sz="1300" dirty="0"/>
           </a:p>
         </p:txBody>
       </p:sp>
       <p:sp>
         <p:nvSpPr>
-          <p:cNvPr id="16" name="Text 11"/>
-          <p:cNvSpPr/>
-          <p:nvPr/>
-        </p:nvSpPr>
-        <p:spPr>
-          <a:xfrm>
-            <a:off x="969264" y="4251960"/>
-            <a:ext cx="4608576" cy="502920"/>
-          </a:xfrm>
-          <a:prstGeom prst="rect">
-            <a:avLst/>
-          </a:prstGeom>
-          <a:noFill/>
-          <a:ln/>
-        </p:spPr>
-        <p:txBody>
-          <a:bodyPr wrap="square" lIns="0" tIns="0" rIns="0" bIns="0" rtlCol="0" anchor="ctr"/>
-          <a:lstStyle/>
-          <a:p>
-            <a:pPr indent="0" marL="0">
+          <p:cNvPr id="24" name="Shape 19"/>
+          <p:cNvSpPr/>
+          <p:nvPr/>
+        </p:nvSpPr>
+        <p:spPr>
+          <a:xfrm>
+            <a:off x="457200" y="5440680"/>
+            <a:ext cx="11274552" cy="0"/>
+          </a:xfrm>
+          <a:prstGeom prst="line">
+            <a:avLst/>
+          </a:prstGeom>
+          <a:noFill/>
+          <a:ln w="12700">
+            <a:solidFill>
+              <a:srgbClr val="24344A"/>
+            </a:solidFill>
+            <a:prstDash val="solid"/>
+          </a:ln>
+        </p:spPr>
+      </p:sp>
+      <p:sp>
+        <p:nvSpPr>
+          <p:cNvPr id="25" name="Text 20"/>
+          <p:cNvSpPr/>
+          <p:nvPr/>
+        </p:nvSpPr>
+        <p:spPr>
+          <a:xfrm>
+            <a:off x="457200" y="5541264"/>
+            <a:ext cx="6400800" cy="274320"/>
+          </a:xfrm>
+          <a:prstGeom prst="rect">
+            <a:avLst/>
+          </a:prstGeom>
+          <a:noFill/>
+          <a:ln/>
+        </p:spPr>
+        <p:txBody>
+          <a:bodyPr wrap="square" rtlCol="0" anchor="ctr"/>
+          <a:lstStyle/>
+          <a:p>
+            <a:pPr algn="l" indent="0" marL="0">
+              <a:buNone/>
+            </a:pPr>
+            <a:r>
+              <a:rPr lang="en-US" sz="1300" b="1" spc="200" kern="0" dirty="0">
+                <a:solidFill>
+                  <a:srgbClr val="00B4D8"/>
+                </a:solidFill>
+                <a:latin typeface="Arial" pitchFamily="34" charset="0"/>
+                <a:ea typeface="Arial" pitchFamily="34" charset="-122"/>
+                <a:cs typeface="Arial" pitchFamily="34" charset="-120"/>
+              </a:rPr>
+              <a:t>Q3 2026 FOCUS</a:t>
+            </a:r>
+            <a:endParaRPr lang="en-US" sz="1300" dirty="0"/>
+          </a:p>
+        </p:txBody>
+      </p:sp>
+      <p:sp>
+        <p:nvSpPr>
+          <p:cNvPr id="26" name="Text 21"/>
+          <p:cNvSpPr/>
+          <p:nvPr/>
+        </p:nvSpPr>
+        <p:spPr>
+          <a:xfrm>
+            <a:off x="457200" y="5870448"/>
+            <a:ext cx="566928" cy="457200"/>
+          </a:xfrm>
+          <a:prstGeom prst="rect">
+            <a:avLst/>
+          </a:prstGeom>
+          <a:noFill/>
+          <a:ln/>
+        </p:spPr>
+        <p:txBody>
+          <a:bodyPr wrap="square" rtlCol="0" anchor="ctr"/>
+          <a:lstStyle/>
+          <a:p>
+            <a:pPr algn="l" indent="0" marL="0">
+              <a:buNone/>
+            </a:pPr>
+            <a:r>
+              <a:rPr lang="en-US" sz="2800" b="1" dirty="0">
+                <a:solidFill>
+                  <a:srgbClr val="00B4D8"/>
+                </a:solidFill>
+                <a:latin typeface="Arial" pitchFamily="34" charset="0"/>
+                <a:ea typeface="Arial" pitchFamily="34" charset="-122"/>
+                <a:cs typeface="Arial" pitchFamily="34" charset="-120"/>
+              </a:rPr>
+              <a:t>01</a:t>
+            </a:r>
+            <a:endParaRPr lang="en-US" sz="2800" dirty="0"/>
+          </a:p>
+        </p:txBody>
+      </p:sp>
+      <p:sp>
+        <p:nvSpPr>
+          <p:cNvPr id="27" name="Text 22"/>
+          <p:cNvSpPr/>
+          <p:nvPr/>
+        </p:nvSpPr>
+        <p:spPr>
+          <a:xfrm>
+            <a:off x="1060704" y="5888736"/>
+            <a:ext cx="2962656" cy="384048"/>
+          </a:xfrm>
+          <a:prstGeom prst="rect">
+            <a:avLst/>
+          </a:prstGeom>
+          <a:noFill/>
+          <a:ln/>
+        </p:spPr>
+        <p:txBody>
+          <a:bodyPr wrap="square" rtlCol="0" anchor="ctr"/>
+          <a:lstStyle/>
+          <a:p>
+            <a:pPr algn="l" indent="0" marL="0">
+              <a:buNone/>
+            </a:pPr>
+            <a:r>
+              <a:rPr lang="en-US" sz="1400" b="1" dirty="0">
+                <a:solidFill>
+                  <a:srgbClr val="FFFFFF"/>
+                </a:solidFill>
+                <a:latin typeface="Arial" pitchFamily="34" charset="0"/>
+                <a:ea typeface="Arial" pitchFamily="34" charset="-122"/>
+                <a:cs typeface="Arial" pitchFamily="34" charset="-120"/>
+              </a:rPr>
+              <a:t>Website refresh</a:t>
+            </a:r>
+            <a:endParaRPr lang="en-US" sz="1400" dirty="0"/>
+          </a:p>
+        </p:txBody>
+      </p:sp>
+      <p:sp>
+        <p:nvSpPr>
+          <p:cNvPr id="28" name="Text 23"/>
+          <p:cNvSpPr/>
+          <p:nvPr/>
+        </p:nvSpPr>
+        <p:spPr>
+          <a:xfrm>
+            <a:off x="457200" y="6355080"/>
+            <a:ext cx="3566160" cy="457200"/>
+          </a:xfrm>
+          <a:prstGeom prst="rect">
+            <a:avLst/>
+          </a:prstGeom>
+          <a:noFill/>
+          <a:ln/>
+        </p:spPr>
+        <p:txBody>
+          <a:bodyPr wrap="square" rtlCol="0" anchor="t"/>
+          <a:lstStyle/>
+          <a:p>
+            <a:pPr algn="l" indent="0" marL="0">
+              <a:lnSpc>
+                <a:spcPct val="105000"/>
+              </a:lnSpc>
               <a:buNone/>
             </a:pPr>
             <a:r>
               <a:rPr lang="en-US" sz="1000" dirty="0">
                 <a:solidFill>
-                  <a:srgbClr val="CBD5E1"/>
-                </a:solidFill>
-                <a:latin typeface="Arial" pitchFamily="34" charset="0"/>
-                <a:ea typeface="Arial" pitchFamily="34" charset="-122"/>
-                <a:cs typeface="Arial" pitchFamily="34" charset="-120"/>
-              </a:rPr>
-              <a:t>New Telehealth-focused demo presentation. Detailed Integration Deck documenting end-to-end product integration process for prospects and partners.</a:t>
+                  <a:srgbClr val="B8C4D0"/>
+                </a:solidFill>
+                <a:latin typeface="Arial" pitchFamily="34" charset="0"/>
+                <a:ea typeface="Arial" pitchFamily="34" charset="-122"/>
+                <a:cs typeface="Arial" pitchFamily="34" charset="-120"/>
+              </a:rPr>
+              <a:t>Create dedicated use case pages for each FitXpress vertical + overhaul the main FitXpress page.</a:t>
             </a:r>
             <a:endParaRPr lang="en-US" sz="1000" dirty="0"/>
           </a:p>
@@ -1379,50 +1829,30 @@
       </p:sp>
       <p:sp>
         <p:nvSpPr>
-          <p:cNvPr id="17" name="Shape 12"/>
-          <p:cNvSpPr/>
-          <p:nvPr/>
-        </p:nvSpPr>
-        <p:spPr>
-          <a:xfrm>
-            <a:off x="6035040" y="1965960"/>
-            <a:ext cx="2743200" cy="1234440"/>
-          </a:xfrm>
-          <a:prstGeom prst="rect">
-            <a:avLst/>
-          </a:prstGeom>
-          <a:solidFill>
-            <a:srgbClr val="16253B"/>
-          </a:solidFill>
-          <a:ln/>
-        </p:spPr>
-      </p:sp>
-      <p:sp>
-        <p:nvSpPr>
-          <p:cNvPr id="18" name="Text 13"/>
-          <p:cNvSpPr/>
-          <p:nvPr/>
-        </p:nvSpPr>
-        <p:spPr>
-          <a:xfrm>
-            <a:off x="6172200" y="2057400"/>
-            <a:ext cx="914400" cy="594360"/>
-          </a:xfrm>
-          <a:prstGeom prst="rect">
-            <a:avLst/>
-          </a:prstGeom>
-          <a:noFill/>
-          <a:ln/>
-        </p:spPr>
-        <p:txBody>
-          <a:bodyPr wrap="square" lIns="0" tIns="0" rIns="0" bIns="0" rtlCol="0" anchor="ctr"/>
-          <a:lstStyle/>
-          <a:p>
-            <a:pPr indent="0" marL="0">
-              <a:buNone/>
-            </a:pPr>
-            <a:r>
-              <a:rPr lang="en-US" sz="4200" b="1" dirty="0">
+          <p:cNvPr id="29" name="Text 24"/>
+          <p:cNvSpPr/>
+          <p:nvPr/>
+        </p:nvSpPr>
+        <p:spPr>
+          <a:xfrm>
+            <a:off x="4297680" y="5870448"/>
+            <a:ext cx="566928" cy="457200"/>
+          </a:xfrm>
+          <a:prstGeom prst="rect">
+            <a:avLst/>
+          </a:prstGeom>
+          <a:noFill/>
+          <a:ln/>
+        </p:spPr>
+        <p:txBody>
+          <a:bodyPr wrap="square" rtlCol="0" anchor="ctr"/>
+          <a:lstStyle/>
+          <a:p>
+            <a:pPr algn="l" indent="0" marL="0">
+              <a:buNone/>
+            </a:pPr>
+            <a:r>
+              <a:rPr lang="en-US" sz="2800" b="1" dirty="0">
                 <a:solidFill>
                   <a:srgbClr val="00B4D8"/>
                 </a:solidFill>
@@ -1430,595 +1860,212 @@
                 <a:ea typeface="Arial" pitchFamily="34" charset="-122"/>
                 <a:cs typeface="Arial" pitchFamily="34" charset="-120"/>
               </a:rPr>
-              <a:t>6</a:t>
-            </a:r>
-            <a:endParaRPr lang="en-US" sz="4200" dirty="0"/>
-          </a:p>
-        </p:txBody>
-      </p:sp>
-      <p:sp>
-        <p:nvSpPr>
-          <p:cNvPr id="19" name="Text 14"/>
-          <p:cNvSpPr/>
-          <p:nvPr/>
-        </p:nvSpPr>
-        <p:spPr>
-          <a:xfrm>
-            <a:off x="6172200" y="2606040"/>
-            <a:ext cx="2377440" cy="502920"/>
-          </a:xfrm>
-          <a:prstGeom prst="rect">
-            <a:avLst/>
-          </a:prstGeom>
-          <a:noFill/>
-          <a:ln/>
-        </p:spPr>
-        <p:txBody>
-          <a:bodyPr wrap="square" lIns="0" tIns="0" rIns="0" bIns="0" rtlCol="0" anchor="ctr"/>
-          <a:lstStyle/>
-          <a:p>
-            <a:pPr indent="0" marL="0">
+              <a:t>02</a:t>
+            </a:r>
+            <a:endParaRPr lang="en-US" sz="2800" dirty="0"/>
+          </a:p>
+        </p:txBody>
+      </p:sp>
+      <p:sp>
+        <p:nvSpPr>
+          <p:cNvPr id="30" name="Text 25"/>
+          <p:cNvSpPr/>
+          <p:nvPr/>
+        </p:nvSpPr>
+        <p:spPr>
+          <a:xfrm>
+            <a:off x="4901184" y="5888736"/>
+            <a:ext cx="2962656" cy="384048"/>
+          </a:xfrm>
+          <a:prstGeom prst="rect">
+            <a:avLst/>
+          </a:prstGeom>
+          <a:noFill/>
+          <a:ln/>
+        </p:spPr>
+        <p:txBody>
+          <a:bodyPr wrap="square" rtlCol="0" anchor="ctr"/>
+          <a:lstStyle/>
+          <a:p>
+            <a:pPr algn="l" indent="0" marL="0">
+              <a:buNone/>
+            </a:pPr>
+            <a:r>
+              <a:rPr lang="en-US" sz="1400" b="1" dirty="0">
+                <a:solidFill>
+                  <a:srgbClr val="FFFFFF"/>
+                </a:solidFill>
+                <a:latin typeface="Arial" pitchFamily="34" charset="0"/>
+                <a:ea typeface="Arial" pitchFamily="34" charset="-122"/>
+                <a:cs typeface="Arial" pitchFamily="34" charset="-120"/>
+              </a:rPr>
+              <a:t>Demo completeness</a:t>
+            </a:r>
+            <a:endParaRPr lang="en-US" sz="1400" dirty="0"/>
+          </a:p>
+        </p:txBody>
+      </p:sp>
+      <p:sp>
+        <p:nvSpPr>
+          <p:cNvPr id="31" name="Text 26"/>
+          <p:cNvSpPr/>
+          <p:nvPr/>
+        </p:nvSpPr>
+        <p:spPr>
+          <a:xfrm>
+            <a:off x="4297680" y="6355080"/>
+            <a:ext cx="3566160" cy="457200"/>
+          </a:xfrm>
+          <a:prstGeom prst="rect">
+            <a:avLst/>
+          </a:prstGeom>
+          <a:noFill/>
+          <a:ln/>
+        </p:spPr>
+        <p:txBody>
+          <a:bodyPr wrap="square" rtlCol="0" anchor="t"/>
+          <a:lstStyle/>
+          <a:p>
+            <a:pPr algn="l" indent="0" marL="0">
+              <a:lnSpc>
+                <a:spcPct val="105000"/>
+              </a:lnSpc>
               <a:buNone/>
             </a:pPr>
             <a:r>
               <a:rPr lang="en-US" sz="1000" dirty="0">
                 <a:solidFill>
-                  <a:srgbClr val="CBD5E1"/>
-                </a:solidFill>
-                <a:latin typeface="Arial" pitchFamily="34" charset="0"/>
-                <a:ea typeface="Arial" pitchFamily="34" charset="-122"/>
-                <a:cs typeface="Arial" pitchFamily="34" charset="-120"/>
-              </a:rPr>
-              <a:t>FitXpress use cases</a:t>
+                  <a:srgbClr val="B8C4D0"/>
+                </a:solidFill>
+                <a:latin typeface="Arial" pitchFamily="34" charset="0"/>
+                <a:ea typeface="Arial" pitchFamily="34" charset="-122"/>
+                <a:cs typeface="Arial" pitchFamily="34" charset="-120"/>
+              </a:rPr>
+              <a:t>Build tailored demo presentations for all FitXpress use cases.</a:t>
             </a:r>
             <a:endParaRPr lang="en-US" sz="1000" dirty="0"/>
           </a:p>
-          <a:p>
-            <a:pPr indent="0" marL="0">
+        </p:txBody>
+      </p:sp>
+      <p:sp>
+        <p:nvSpPr>
+          <p:cNvPr id="32" name="Text 27"/>
+          <p:cNvSpPr/>
+          <p:nvPr/>
+        </p:nvSpPr>
+        <p:spPr>
+          <a:xfrm>
+            <a:off x="8138160" y="5870448"/>
+            <a:ext cx="566928" cy="457200"/>
+          </a:xfrm>
+          <a:prstGeom prst="rect">
+            <a:avLst/>
+          </a:prstGeom>
+          <a:noFill/>
+          <a:ln/>
+        </p:spPr>
+        <p:txBody>
+          <a:bodyPr wrap="square" rtlCol="0" anchor="ctr"/>
+          <a:lstStyle/>
+          <a:p>
+            <a:pPr algn="l" indent="0" marL="0">
+              <a:buNone/>
+            </a:pPr>
+            <a:r>
+              <a:rPr lang="en-US" sz="2800" b="1" dirty="0">
+                <a:solidFill>
+                  <a:srgbClr val="00B4D8"/>
+                </a:solidFill>
+                <a:latin typeface="Arial" pitchFamily="34" charset="0"/>
+                <a:ea typeface="Arial" pitchFamily="34" charset="-122"/>
+                <a:cs typeface="Arial" pitchFamily="34" charset="-120"/>
+              </a:rPr>
+              <a:t>03</a:t>
+            </a:r>
+            <a:endParaRPr lang="en-US" sz="2800" dirty="0"/>
+          </a:p>
+        </p:txBody>
+      </p:sp>
+      <p:sp>
+        <p:nvSpPr>
+          <p:cNvPr id="33" name="Text 28"/>
+          <p:cNvSpPr/>
+          <p:nvPr/>
+        </p:nvSpPr>
+        <p:spPr>
+          <a:xfrm>
+            <a:off x="8741664" y="5888736"/>
+            <a:ext cx="2962656" cy="384048"/>
+          </a:xfrm>
+          <a:prstGeom prst="rect">
+            <a:avLst/>
+          </a:prstGeom>
+          <a:noFill/>
+          <a:ln/>
+        </p:spPr>
+        <p:txBody>
+          <a:bodyPr wrap="square" rtlCol="0" anchor="ctr"/>
+          <a:lstStyle/>
+          <a:p>
+            <a:pPr algn="l" indent="0" marL="0">
+              <a:buNone/>
+            </a:pPr>
+            <a:r>
+              <a:rPr lang="en-US" sz="1400" b="1" dirty="0">
+                <a:solidFill>
+                  <a:srgbClr val="FFFFFF"/>
+                </a:solidFill>
+                <a:latin typeface="Arial" pitchFamily="34" charset="0"/>
+                <a:ea typeface="Arial" pitchFamily="34" charset="-122"/>
+                <a:cs typeface="Arial" pitchFamily="34" charset="-120"/>
+              </a:rPr>
+              <a:t>Outbound scale</a:t>
+            </a:r>
+            <a:endParaRPr lang="en-US" sz="1400" dirty="0"/>
+          </a:p>
+        </p:txBody>
+      </p:sp>
+      <p:sp>
+        <p:nvSpPr>
+          <p:cNvPr id="34" name="Text 29"/>
+          <p:cNvSpPr/>
+          <p:nvPr/>
+        </p:nvSpPr>
+        <p:spPr>
+          <a:xfrm>
+            <a:off x="8138160" y="6355080"/>
+            <a:ext cx="3566160" cy="457200"/>
+          </a:xfrm>
+          <a:prstGeom prst="rect">
+            <a:avLst/>
+          </a:prstGeom>
+          <a:noFill/>
+          <a:ln/>
+        </p:spPr>
+        <p:txBody>
+          <a:bodyPr wrap="square" rtlCol="0" anchor="t"/>
+          <a:lstStyle/>
+          <a:p>
+            <a:pPr algn="l" indent="0" marL="0">
+              <a:lnSpc>
+                <a:spcPct val="105000"/>
+              </a:lnSpc>
               <a:buNone/>
             </a:pPr>
             <a:r>
               <a:rPr lang="en-US" sz="1000" dirty="0">
                 <a:solidFill>
-                  <a:srgbClr val="CBD5E1"/>
-                </a:solidFill>
-                <a:latin typeface="Arial" pitchFamily="34" charset="0"/>
-                <a:ea typeface="Arial" pitchFamily="34" charset="-122"/>
-                <a:cs typeface="Arial" pitchFamily="34" charset="-120"/>
-              </a:rPr>
-              <a:t>mapped &amp; published</a:t>
+                  <a:srgbClr val="B8C4D0"/>
+                </a:solidFill>
+                <a:latin typeface="Arial" pitchFamily="34" charset="0"/>
+                <a:ea typeface="Arial" pitchFamily="34" charset="-122"/>
+                <a:cs typeface="Arial" pitchFamily="34" charset="-120"/>
+              </a:rPr>
+              <a:t>Launch upgraded outbound sequences. Activate 2 additional sales manager accounts.</a:t>
             </a:r>
             <a:endParaRPr lang="en-US" sz="1000" dirty="0"/>
           </a:p>
         </p:txBody>
-      </p:sp>
-      <p:sp>
-        <p:nvSpPr>
-          <p:cNvPr id="20" name="Shape 15"/>
-          <p:cNvSpPr/>
-          <p:nvPr/>
-        </p:nvSpPr>
-        <p:spPr>
-          <a:xfrm>
-            <a:off x="6035040" y="3337560"/>
-            <a:ext cx="2743200" cy="1097280"/>
-          </a:xfrm>
-          <a:prstGeom prst="rect">
-            <a:avLst/>
-          </a:prstGeom>
-          <a:solidFill>
-            <a:srgbClr val="16253B"/>
-          </a:solidFill>
-          <a:ln/>
-        </p:spPr>
-      </p:sp>
-      <p:sp>
-        <p:nvSpPr>
-          <p:cNvPr id="21" name="Text 16"/>
-          <p:cNvSpPr/>
-          <p:nvPr/>
-        </p:nvSpPr>
-        <p:spPr>
-          <a:xfrm>
-            <a:off x="6172200" y="3401568"/>
-            <a:ext cx="2377440" cy="228600"/>
-          </a:xfrm>
-          <a:prstGeom prst="rect">
-            <a:avLst/>
-          </a:prstGeom>
-          <a:noFill/>
-          <a:ln/>
-        </p:spPr>
-        <p:txBody>
-          <a:bodyPr wrap="square" lIns="0" tIns="0" rIns="0" bIns="0" rtlCol="0" anchor="ctr"/>
-          <a:lstStyle/>
-          <a:p>
-            <a:pPr indent="0" marL="0">
-              <a:buNone/>
-            </a:pPr>
-            <a:r>
-              <a:rPr lang="en-US" sz="900" b="1" spc="150" kern="0" dirty="0">
-                <a:solidFill>
-                  <a:srgbClr val="00B4D8"/>
-                </a:solidFill>
-                <a:latin typeface="Arial" pitchFamily="34" charset="0"/>
-                <a:ea typeface="Arial" pitchFamily="34" charset="-122"/>
-                <a:cs typeface="Arial" pitchFamily="34" charset="-120"/>
-              </a:rPr>
-              <a:t>PRIMARY OUTPUT</a:t>
-            </a:r>
-            <a:endParaRPr lang="en-US" sz="900" dirty="0"/>
-          </a:p>
-        </p:txBody>
-      </p:sp>
-      <p:sp>
-        <p:nvSpPr>
-          <p:cNvPr id="22" name="Text 17"/>
-          <p:cNvSpPr/>
-          <p:nvPr/>
-        </p:nvSpPr>
-        <p:spPr>
-          <a:xfrm>
-            <a:off x="6172200" y="3657600"/>
-            <a:ext cx="2377440" cy="685800"/>
-          </a:xfrm>
-          <a:prstGeom prst="rect">
-            <a:avLst/>
-          </a:prstGeom>
-          <a:noFill/>
-          <a:ln/>
-        </p:spPr>
-        <p:txBody>
-          <a:bodyPr wrap="square" lIns="0" tIns="0" rIns="0" bIns="0" rtlCol="0" anchor="ctr"/>
-          <a:lstStyle/>
-          <a:p>
-            <a:pPr indent="0" marL="0">
-              <a:buNone/>
-            </a:pPr>
-            <a:r>
-              <a:rPr lang="en-US" sz="950" dirty="0">
-                <a:solidFill>
-                  <a:srgbClr val="CBD5E1"/>
-                </a:solidFill>
-                <a:latin typeface="Arial" pitchFamily="34" charset="0"/>
-                <a:ea typeface="Arial" pitchFamily="34" charset="-122"/>
-                <a:cs typeface="Arial" pitchFamily="34" charset="-120"/>
-              </a:rPr>
-              <a:t>Demonstrated FitXpress breadth across healthcare verticals. Built content infrastructure (use-case pages, integration docs) and sales assets (demos, decks) to support pipeline scaling.</a:t>
-            </a:r>
-            <a:endParaRPr lang="en-US" sz="950" dirty="0"/>
-          </a:p>
-        </p:txBody>
-      </p:sp>
-      <p:sp>
-        <p:nvSpPr>
-          <p:cNvPr id="23" name="Shape 18"/>
-          <p:cNvSpPr/>
-          <p:nvPr/>
-        </p:nvSpPr>
-        <p:spPr>
-          <a:xfrm>
-            <a:off x="548640" y="4480560"/>
-            <a:ext cx="8046720" cy="9144"/>
-          </a:xfrm>
-          <a:prstGeom prst="rect">
-            <a:avLst/>
-          </a:prstGeom>
-          <a:solidFill>
-            <a:srgbClr val="1E3A5F"/>
-          </a:solidFill>
-          <a:ln/>
-        </p:spPr>
-      </p:sp>
-      <p:sp>
-        <p:nvSpPr>
-          <p:cNvPr id="24" name="Text 19"/>
-          <p:cNvSpPr/>
-          <p:nvPr/>
-        </p:nvSpPr>
-        <p:spPr>
-          <a:xfrm>
-            <a:off x="548640" y="4572000"/>
-            <a:ext cx="8046720" cy="256032"/>
-          </a:xfrm>
-          <a:prstGeom prst="rect">
-            <a:avLst/>
-          </a:prstGeom>
-          <a:noFill/>
-          <a:ln/>
-        </p:spPr>
-        <p:txBody>
-          <a:bodyPr wrap="square" lIns="0" tIns="0" rIns="0" bIns="0" rtlCol="0" anchor="ctr"/>
-          <a:lstStyle/>
-          <a:p>
-            <a:pPr indent="0" marL="0">
-              <a:buNone/>
-            </a:pPr>
-            <a:r>
-              <a:rPr lang="en-US" sz="1100" b="1" spc="200" kern="0" dirty="0">
-                <a:solidFill>
-                  <a:srgbClr val="00B4D8"/>
-                </a:solidFill>
-                <a:latin typeface="Arial" pitchFamily="34" charset="0"/>
-                <a:ea typeface="Arial" pitchFamily="34" charset="-122"/>
-                <a:cs typeface="Arial" pitchFamily="34" charset="-120"/>
-              </a:rPr>
-              <a:t>Q3'2026 FOCUS</a:t>
-            </a:r>
-            <a:endParaRPr lang="en-US" sz="1100" dirty="0"/>
-          </a:p>
-        </p:txBody>
-      </p:sp>
-      <p:sp>
-        <p:nvSpPr>
-          <p:cNvPr id="25" name="Text 20"/>
-          <p:cNvSpPr/>
-          <p:nvPr/>
-        </p:nvSpPr>
-        <p:spPr>
-          <a:xfrm>
-            <a:off x="548640" y="4828032"/>
-            <a:ext cx="457200" cy="256032"/>
-          </a:xfrm>
-          <a:prstGeom prst="rect">
-            <a:avLst/>
-          </a:prstGeom>
-          <a:noFill/>
-          <a:ln/>
-        </p:spPr>
-        <p:txBody>
-          <a:bodyPr wrap="square" lIns="0" tIns="0" rIns="0" bIns="0" rtlCol="0" anchor="ctr"/>
-          <a:lstStyle/>
-          <a:p>
-            <a:pPr indent="0" marL="0">
-              <a:buNone/>
-            </a:pPr>
-            <a:r>
-              <a:rPr lang="en-US" sz="1800" b="1" dirty="0">
-                <a:solidFill>
-                  <a:srgbClr val="00B4D8"/>
-                </a:solidFill>
-                <a:latin typeface="Arial" pitchFamily="34" charset="0"/>
-                <a:ea typeface="Arial" pitchFamily="34" charset="-122"/>
-                <a:cs typeface="Arial" pitchFamily="34" charset="-120"/>
-              </a:rPr>
-              <a:t>01</a:t>
-            </a:r>
-            <a:endParaRPr lang="en-US" sz="1800" dirty="0"/>
-          </a:p>
-        </p:txBody>
-      </p:sp>
-      <p:sp>
-        <p:nvSpPr>
-          <p:cNvPr id="26" name="Text 21"/>
-          <p:cNvSpPr/>
-          <p:nvPr/>
-        </p:nvSpPr>
-        <p:spPr>
-          <a:xfrm>
-            <a:off x="960120" y="4828032"/>
-            <a:ext cx="2057400" cy="256032"/>
-          </a:xfrm>
-          <a:prstGeom prst="rect">
-            <a:avLst/>
-          </a:prstGeom>
-          <a:noFill/>
-          <a:ln/>
-        </p:spPr>
-        <p:txBody>
-          <a:bodyPr wrap="square" lIns="0" tIns="0" rIns="0" bIns="0" rtlCol="0" anchor="ctr"/>
-          <a:lstStyle/>
-          <a:p>
-            <a:pPr indent="0" marL="0">
-              <a:buNone/>
-            </a:pPr>
-            <a:r>
-              <a:rPr lang="en-US" sz="1300" b="1" dirty="0">
-                <a:solidFill>
-                  <a:srgbClr val="FFFFFF"/>
-                </a:solidFill>
-                <a:latin typeface="Arial" pitchFamily="34" charset="0"/>
-                <a:ea typeface="Arial" pitchFamily="34" charset="-122"/>
-                <a:cs typeface="Arial" pitchFamily="34" charset="-120"/>
-              </a:rPr>
-              <a:t>Website refresh</a:t>
-            </a:r>
-            <a:endParaRPr lang="en-US" sz="1300" dirty="0"/>
-          </a:p>
-        </p:txBody>
-      </p:sp>
-      <p:sp>
-        <p:nvSpPr>
-          <p:cNvPr id="27" name="Text 22"/>
-          <p:cNvSpPr/>
-          <p:nvPr/>
-        </p:nvSpPr>
-        <p:spPr>
-          <a:xfrm>
-            <a:off x="548640" y="5102352"/>
-            <a:ext cx="2468880" cy="457200"/>
-          </a:xfrm>
-          <a:prstGeom prst="rect">
-            <a:avLst/>
-          </a:prstGeom>
-          <a:noFill/>
-          <a:ln/>
-        </p:spPr>
-        <p:txBody>
-          <a:bodyPr wrap="square" lIns="0" tIns="0" rIns="0" bIns="0" rtlCol="0" anchor="ctr"/>
-          <a:lstStyle/>
-          <a:p>
-            <a:pPr indent="0" marL="0">
-              <a:buNone/>
-            </a:pPr>
-            <a:r>
-              <a:rPr lang="en-US" sz="950" dirty="0">
-                <a:solidFill>
-                  <a:srgbClr val="CBD5E1"/>
-                </a:solidFill>
-                <a:latin typeface="Arial" pitchFamily="34" charset="0"/>
-                <a:ea typeface="Arial" pitchFamily="34" charset="-122"/>
-                <a:cs typeface="Arial" pitchFamily="34" charset="-120"/>
-              </a:rPr>
-              <a:t>Create dedicated use case pages for each FitXpress vertical + overhaul main FitXpress page. Full site-wide refresh to reflect expanded scope.</a:t>
-            </a:r>
-            <a:endParaRPr lang="en-US" sz="950" dirty="0"/>
-          </a:p>
-        </p:txBody>
-      </p:sp>
-      <p:sp>
-        <p:nvSpPr>
-          <p:cNvPr id="28" name="Text 23"/>
-          <p:cNvSpPr/>
-          <p:nvPr/>
-        </p:nvSpPr>
-        <p:spPr>
-          <a:xfrm>
-            <a:off x="3246120" y="4828032"/>
-            <a:ext cx="457200" cy="256032"/>
-          </a:xfrm>
-          <a:prstGeom prst="rect">
-            <a:avLst/>
-          </a:prstGeom>
-          <a:noFill/>
-          <a:ln/>
-        </p:spPr>
-        <p:txBody>
-          <a:bodyPr wrap="square" lIns="0" tIns="0" rIns="0" bIns="0" rtlCol="0" anchor="ctr"/>
-          <a:lstStyle/>
-          <a:p>
-            <a:pPr indent="0" marL="0">
-              <a:buNone/>
-            </a:pPr>
-            <a:r>
-              <a:rPr lang="en-US" sz="1800" b="1" dirty="0">
-                <a:solidFill>
-                  <a:srgbClr val="00B4D8"/>
-                </a:solidFill>
-                <a:latin typeface="Arial" pitchFamily="34" charset="0"/>
-                <a:ea typeface="Arial" pitchFamily="34" charset="-122"/>
-                <a:cs typeface="Arial" pitchFamily="34" charset="-120"/>
-              </a:rPr>
-              <a:t>02</a:t>
-            </a:r>
-            <a:endParaRPr lang="en-US" sz="1800" dirty="0"/>
-          </a:p>
-        </p:txBody>
-      </p:sp>
-      <p:sp>
-        <p:nvSpPr>
-          <p:cNvPr id="29" name="Text 24"/>
-          <p:cNvSpPr/>
-          <p:nvPr/>
-        </p:nvSpPr>
-        <p:spPr>
-          <a:xfrm>
-            <a:off x="3657600" y="4828032"/>
-            <a:ext cx="2057400" cy="256032"/>
-          </a:xfrm>
-          <a:prstGeom prst="rect">
-            <a:avLst/>
-          </a:prstGeom>
-          <a:noFill/>
-          <a:ln/>
-        </p:spPr>
-        <p:txBody>
-          <a:bodyPr wrap="square" lIns="0" tIns="0" rIns="0" bIns="0" rtlCol="0" anchor="ctr"/>
-          <a:lstStyle/>
-          <a:p>
-            <a:pPr indent="0" marL="0">
-              <a:buNone/>
-            </a:pPr>
-            <a:r>
-              <a:rPr lang="en-US" sz="1300" b="1" dirty="0">
-                <a:solidFill>
-                  <a:srgbClr val="FFFFFF"/>
-                </a:solidFill>
-                <a:latin typeface="Arial" pitchFamily="34" charset="0"/>
-                <a:ea typeface="Arial" pitchFamily="34" charset="-122"/>
-                <a:cs typeface="Arial" pitchFamily="34" charset="-120"/>
-              </a:rPr>
-              <a:t>Demo completeness</a:t>
-            </a:r>
-            <a:endParaRPr lang="en-US" sz="1300" dirty="0"/>
-          </a:p>
-        </p:txBody>
-      </p:sp>
-      <p:sp>
-        <p:nvSpPr>
-          <p:cNvPr id="30" name="Text 25"/>
-          <p:cNvSpPr/>
-          <p:nvPr/>
-        </p:nvSpPr>
-        <p:spPr>
-          <a:xfrm>
-            <a:off x="3246120" y="5102352"/>
-            <a:ext cx="2468880" cy="457200"/>
-          </a:xfrm>
-          <a:prstGeom prst="rect">
-            <a:avLst/>
-          </a:prstGeom>
-          <a:noFill/>
-          <a:ln/>
-        </p:spPr>
-        <p:txBody>
-          <a:bodyPr wrap="square" lIns="0" tIns="0" rIns="0" bIns="0" rtlCol="0" anchor="ctr"/>
-          <a:lstStyle/>
-          <a:p>
-            <a:pPr indent="0" marL="0">
-              <a:buNone/>
-            </a:pPr>
-            <a:r>
-              <a:rPr lang="en-US" sz="950" dirty="0">
-                <a:solidFill>
-                  <a:srgbClr val="CBD5E1"/>
-                </a:solidFill>
-                <a:latin typeface="Arial" pitchFamily="34" charset="0"/>
-                <a:ea typeface="Arial" pitchFamily="34" charset="-122"/>
-                <a:cs typeface="Arial" pitchFamily="34" charset="-120"/>
-              </a:rPr>
-              <a:t>Build tailored demo presentations for all FitXpress use cases — enabling sales to show relevant stories per vertical.</a:t>
-            </a:r>
-            <a:endParaRPr lang="en-US" sz="950" dirty="0"/>
-          </a:p>
-        </p:txBody>
-      </p:sp>
-      <p:sp>
-        <p:nvSpPr>
-          <p:cNvPr id="31" name="Text 26"/>
-          <p:cNvSpPr/>
-          <p:nvPr/>
-        </p:nvSpPr>
-        <p:spPr>
-          <a:xfrm>
-            <a:off x="5943600" y="4828032"/>
-            <a:ext cx="457200" cy="256032"/>
-          </a:xfrm>
-          <a:prstGeom prst="rect">
-            <a:avLst/>
-          </a:prstGeom>
-          <a:noFill/>
-          <a:ln/>
-        </p:spPr>
-        <p:txBody>
-          <a:bodyPr wrap="square" lIns="0" tIns="0" rIns="0" bIns="0" rtlCol="0" anchor="ctr"/>
-          <a:lstStyle/>
-          <a:p>
-            <a:pPr indent="0" marL="0">
-              <a:buNone/>
-            </a:pPr>
-            <a:r>
-              <a:rPr lang="en-US" sz="1800" b="1" dirty="0">
-                <a:solidFill>
-                  <a:srgbClr val="00B4D8"/>
-                </a:solidFill>
-                <a:latin typeface="Arial" pitchFamily="34" charset="0"/>
-                <a:ea typeface="Arial" pitchFamily="34" charset="-122"/>
-                <a:cs typeface="Arial" pitchFamily="34" charset="-120"/>
-              </a:rPr>
-              <a:t>03</a:t>
-            </a:r>
-            <a:endParaRPr lang="en-US" sz="1800" dirty="0"/>
-          </a:p>
-        </p:txBody>
-      </p:sp>
-      <p:sp>
-        <p:nvSpPr>
-          <p:cNvPr id="32" name="Text 27"/>
-          <p:cNvSpPr/>
-          <p:nvPr/>
-        </p:nvSpPr>
-        <p:spPr>
-          <a:xfrm>
-            <a:off x="6355080" y="4828032"/>
-            <a:ext cx="2057400" cy="256032"/>
-          </a:xfrm>
-          <a:prstGeom prst="rect">
-            <a:avLst/>
-          </a:prstGeom>
-          <a:noFill/>
-          <a:ln/>
-        </p:spPr>
-        <p:txBody>
-          <a:bodyPr wrap="square" lIns="0" tIns="0" rIns="0" bIns="0" rtlCol="0" anchor="ctr"/>
-          <a:lstStyle/>
-          <a:p>
-            <a:pPr indent="0" marL="0">
-              <a:buNone/>
-            </a:pPr>
-            <a:r>
-              <a:rPr lang="en-US" sz="1300" b="1" dirty="0">
-                <a:solidFill>
-                  <a:srgbClr val="FFFFFF"/>
-                </a:solidFill>
-                <a:latin typeface="Arial" pitchFamily="34" charset="0"/>
-                <a:ea typeface="Arial" pitchFamily="34" charset="-122"/>
-                <a:cs typeface="Arial" pitchFamily="34" charset="-120"/>
-              </a:rPr>
-              <a:t>Outbound scale</a:t>
-            </a:r>
-            <a:endParaRPr lang="en-US" sz="1300" dirty="0"/>
-          </a:p>
-        </p:txBody>
-      </p:sp>
-      <p:sp>
-        <p:nvSpPr>
-          <p:cNvPr id="33" name="Text 28"/>
-          <p:cNvSpPr/>
-          <p:nvPr/>
-        </p:nvSpPr>
-        <p:spPr>
-          <a:xfrm>
-            <a:off x="5943600" y="5102352"/>
-            <a:ext cx="2468880" cy="457200"/>
-          </a:xfrm>
-          <a:prstGeom prst="rect">
-            <a:avLst/>
-          </a:prstGeom>
-          <a:noFill/>
-          <a:ln/>
-        </p:spPr>
-        <p:txBody>
-          <a:bodyPr wrap="square" lIns="0" tIns="0" rIns="0" bIns="0" rtlCol="0" anchor="ctr"/>
-          <a:lstStyle/>
-          <a:p>
-            <a:pPr indent="0" marL="0">
-              <a:buNone/>
-            </a:pPr>
-            <a:r>
-              <a:rPr lang="en-US" sz="950" dirty="0">
-                <a:solidFill>
-                  <a:srgbClr val="CBD5E1"/>
-                </a:solidFill>
-                <a:latin typeface="Arial" pitchFamily="34" charset="0"/>
-                <a:ea typeface="Arial" pitchFamily="34" charset="-122"/>
-                <a:cs typeface="Arial" pitchFamily="34" charset="-120"/>
-              </a:rPr>
-              <a:t>Launch upgraded outbound sequences. Activate 2 additional sales manager accounts for full pipeline coverage.</a:t>
-            </a:r>
-            <a:endParaRPr lang="en-US" sz="950" dirty="0"/>
-          </a:p>
-        </p:txBody>
-      </p:sp>
-      <p:sp>
-        <p:nvSpPr>
-          <p:cNvPr id="34" name="Shape 29"/>
-          <p:cNvSpPr/>
-          <p:nvPr/>
-        </p:nvSpPr>
-        <p:spPr>
-          <a:xfrm>
-            <a:off x="0" y="5106924"/>
-            <a:ext cx="9144000" cy="36576"/>
-          </a:xfrm>
-          <a:prstGeom prst="rect">
-            <a:avLst/>
-          </a:prstGeom>
-          <a:solidFill>
-            <a:srgbClr val="00B4D8"/>
-          </a:solidFill>
-          <a:ln/>
-        </p:spPr>
       </p:sp>
     </p:spTree>
   </p:cSld>

</xml_diff>